<commit_message>
Remove final reproduction summary slide
</commit_message>
<xml_diff>
--- a/DroPE_presentation.pptx
+++ b/DroPE_presentation.pptx
@@ -2,20 +2,19 @@
 <file path=ppt/presentation.xml><?xml version="1.0" encoding="utf-8"?>
 <p:presentation xmlns:p="http://schemas.openxmlformats.org/presentationml/2006/main">
   <p:sldMasterIdLst>
-    <p:sldMasterId xmlns:r="http://schemas.openxmlformats.org/officeDocument/2006/relationships" id="2147483648" r:id="R1e233221e4474622"/>
+    <p:sldMasterId xmlns:r="http://schemas.openxmlformats.org/officeDocument/2006/relationships" id="2147483648" r:id="Rb16782c1e0d04cb4"/>
   </p:sldMasterIdLst>
   <p:notesMasterIdLst>
-    <p:notesMasterId xmlns:r="http://schemas.openxmlformats.org/officeDocument/2006/relationships" r:id="R0e41a1ab6d294c0a"/>
+    <p:notesMasterId xmlns:r="http://schemas.openxmlformats.org/officeDocument/2006/relationships" r:id="Rdf9c2cb7331f4523"/>
   </p:notesMasterIdLst>
   <p:sldIdLst>
-    <p:sldId xmlns:r="http://schemas.openxmlformats.org/officeDocument/2006/relationships" id="256" r:id="R38ba22f82c80415f"/>
-    <p:sldId xmlns:r="http://schemas.openxmlformats.org/officeDocument/2006/relationships" id="257" r:id="R8404f70c9d074b97"/>
-    <p:sldId xmlns:r="http://schemas.openxmlformats.org/officeDocument/2006/relationships" id="258" r:id="Rb2dbb915c62f4560"/>
-    <p:sldId xmlns:r="http://schemas.openxmlformats.org/officeDocument/2006/relationships" id="259" r:id="Rd2a1096cbc8b48cb"/>
-    <p:sldId xmlns:r="http://schemas.openxmlformats.org/officeDocument/2006/relationships" id="260" r:id="R8e839a0b866a46f9"/>
-    <p:sldId xmlns:r="http://schemas.openxmlformats.org/officeDocument/2006/relationships" id="261" r:id="R2b022c89411a47b7"/>
-    <p:sldId xmlns:r="http://schemas.openxmlformats.org/officeDocument/2006/relationships" id="262" r:id="R348f9de378a948f2"/>
-    <p:sldId xmlns:r="http://schemas.openxmlformats.org/officeDocument/2006/relationships" id="263" r:id="Rbe3ad85873a2453b"/>
+    <p:sldId xmlns:r="http://schemas.openxmlformats.org/officeDocument/2006/relationships" id="256" r:id="R445debc888e94ba5"/>
+    <p:sldId xmlns:r="http://schemas.openxmlformats.org/officeDocument/2006/relationships" id="257" r:id="Rd26e367302384f3a"/>
+    <p:sldId xmlns:r="http://schemas.openxmlformats.org/officeDocument/2006/relationships" id="258" r:id="R3496e53ff27c4859"/>
+    <p:sldId xmlns:r="http://schemas.openxmlformats.org/officeDocument/2006/relationships" id="259" r:id="Rd1d0b930725241cd"/>
+    <p:sldId xmlns:r="http://schemas.openxmlformats.org/officeDocument/2006/relationships" id="260" r:id="Rf1b0c605f7e14eec"/>
+    <p:sldId xmlns:r="http://schemas.openxmlformats.org/officeDocument/2006/relationships" id="261" r:id="Rf0506515d12f4ca8"/>
+    <p:sldId xmlns:r="http://schemas.openxmlformats.org/officeDocument/2006/relationships" id="262" r:id="R8a54493acc5c4e05"/>
   </p:sldIdLst>
   <p:sldSz cx="12192000" cy="6858000"/>
   <p:notesSz cx="6858000" cy="9144000"/>
@@ -934,76 +933,6 @@
 </p:notes>
 </file>
 
-<file path=ppt/notesSlides/notesSlide8.xml><?xml version="1.0" encoding="utf-8"?>
-<p:notes xmlns:p="http://schemas.openxmlformats.org/presentationml/2006/main">
-  <p:cSld>
-    <p:spTree>
-      <p:nvGrpSpPr>
-        <p:cNvPr id="1" name=""/>
-        <p:cNvGrpSpPr/>
-        <p:nvPr/>
-      </p:nvGrpSpPr>
-      <p:grpSpPr>
-        <a:xfrm xmlns:a="http://schemas.openxmlformats.org/drawingml/2006/main"/>
-      </p:grpSpPr>
-      <p:sp>
-        <p:nvSpPr>
-          <p:cNvPr id="2" name="Slide Image Placeholder 1"/>
-          <p:cNvSpPr>
-            <a:spLocks xmlns:a="http://schemas.openxmlformats.org/drawingml/2006/main" noGrp="1"/>
-          </p:cNvSpPr>
-          <p:nvPr>
-            <p:ph type="sldImg" idx="0"/>
-          </p:nvPr>
-        </p:nvSpPr>
-        <p:spPr/>
-      </p:sp>
-      <p:sp>
-        <p:nvSpPr>
-          <p:cNvPr id="3" name="Notes Placeholder 2"/>
-          <p:cNvSpPr>
-            <a:spLocks xmlns:a="http://schemas.openxmlformats.org/drawingml/2006/main" noGrp="1"/>
-          </p:cNvSpPr>
-          <p:nvPr>
-            <p:ph type="body" idx="1"/>
-          </p:nvPr>
-        </p:nvSpPr>
-        <p:spPr/>
-        <p:txBody>
-          <a:bodyPr xmlns:a="http://schemas.openxmlformats.org/drawingml/2006/main"/>
-          <a:lstStyle xmlns:a="http://schemas.openxmlformats.org/drawingml/2006/main"/>
-          <a:p xmlns:a="http://schemas.openxmlformats.org/drawingml/2006/main">
-            <a:r>
-              <a:t>Код авторов запущен на CPU в Windows. Готовый авторский 7B checkpoint проверен только на доступ к config/index/первому 1MiB весов. Полная генерация 7B и LongBench не запускались. CUDA/NF4 сценарий подготовлен, но не валидирован полным инференсом. Выводы ограничены локальными structural checks и абляцией. Источники: статья, GitHub, HuggingFace и локальные JSON/логи.</a:t>
-            </a:r>
-          </a:p>
-        </p:txBody>
-      </p:sp>
-      <p:sp>
-        <p:nvSpPr>
-          <p:cNvPr id="4" name="Slide Number Placeholder 3"/>
-          <p:cNvSpPr>
-            <a:spLocks xmlns:a="http://schemas.openxmlformats.org/drawingml/2006/main" noGrp="1"/>
-          </p:cNvSpPr>
-          <p:nvPr>
-            <p:ph type="sldNum" idx="5"/>
-          </p:nvPr>
-        </p:nvSpPr>
-        <p:spPr/>
-        <p:txBody>
-          <a:bodyPr xmlns:a="http://schemas.openxmlformats.org/drawingml/2006/main"/>
-          <a:lstStyle xmlns:a="http://schemas.openxmlformats.org/drawingml/2006/main"/>
-          <a:p xmlns:a="http://schemas.openxmlformats.org/drawingml/2006/main"/>
-        </p:txBody>
-      </p:sp>
-    </p:spTree>
-  </p:cSld>
-  <p:clrMapOvr>
-    <a:masterClrMapping xmlns:a="http://schemas.openxmlformats.org/drawingml/2006/main"/>
-  </p:clrMapOvr>
-</p:notes>
-</file>
-
 <file path=ppt/slideLayouts/slideLayout1.xml><?xml version="1.0" encoding="utf-8"?>
 <p:sldLayout xmlns:p="http://schemas.openxmlformats.org/presentationml/2006/main" type="title">
   <p:cSld name="Title Slide">
@@ -1042,7 +971,7 @@
   </p:cSld>
   <p:clrMap bg1="lt1" tx1="dk1" bg2="lt2" tx2="dk2" accent1="accent1" accent2="accent2" accent3="accent3" accent4="accent4" accent5="accent5" accent6="accent6" hlink="hlink" folHlink="folHlink"/>
   <p:sldLayoutIdLst>
-    <p:sldLayoutId xmlns:r="http://schemas.openxmlformats.org/officeDocument/2006/relationships" id="2147483649" r:id="R4e57af546efd4127"/>
+    <p:sldLayoutId xmlns:r="http://schemas.openxmlformats.org/officeDocument/2006/relationships" id="2147483649" r:id="R58bb4c65a7384dc8"/>
   </p:sldLayoutIdLst>
   <p:txStyles>
     <p:titleStyle>
@@ -1593,7 +1522,7 @@
           <p:cNvPr id="6" name="">
             <a:extLst xmlns:a="http://schemas.openxmlformats.org/drawingml/2006/main">
               <a:ext uri="{FF2B5EF4-FFF2-40B4-BE49-F238E27FC236}">
-                <a16:creationId xmlns:a16="http://schemas.microsoft.com/office/drawing/2014/main" id="{2D9C7378-A381-4089-8BE6-3E839D3A5640}"/>
+                <a16:creationId xmlns:a16="http://schemas.microsoft.com/office/drawing/2014/main" id="{C07719FC-06AA-4443-84C3-AE8DA262B156}"/>
               </a:ext>
             </a:extLst>
           </p:cNvPr>
@@ -1650,7 +1579,7 @@
           <p:cNvPr id="2" name="">
             <a:extLst xmlns:a="http://schemas.openxmlformats.org/drawingml/2006/main">
               <a:ext uri="{FF2B5EF4-FFF2-40B4-BE49-F238E27FC236}">
-                <a16:creationId xmlns:a16="http://schemas.microsoft.com/office/drawing/2014/main" id="{90292CF9-F75B-4896-899C-1A95A2D69AA5}"/>
+                <a16:creationId xmlns:a16="http://schemas.microsoft.com/office/drawing/2014/main" id="{679586C2-F8F2-4092-9435-5FCF4231AC7F}"/>
               </a:ext>
             </a:extLst>
           </p:cNvPr>
@@ -1730,7 +1659,7 @@
           <p:cNvPr id="3" name="">
             <a:extLst xmlns:a="http://schemas.openxmlformats.org/drawingml/2006/main">
               <a:ext uri="{FF2B5EF4-FFF2-40B4-BE49-F238E27FC236}">
-                <a16:creationId xmlns:a16="http://schemas.microsoft.com/office/drawing/2014/main" id="{FE3F31E8-9E87-459F-A108-3AA42DA4DAB8}"/>
+                <a16:creationId xmlns:a16="http://schemas.microsoft.com/office/drawing/2014/main" id="{2F6AF88D-DD48-43FF-826E-6D80C25408D4}"/>
               </a:ext>
             </a:extLst>
           </p:cNvPr>
@@ -1810,7 +1739,7 @@
           <p:cNvPr id="4" name="">
             <a:extLst xmlns:a="http://schemas.openxmlformats.org/drawingml/2006/main">
               <a:ext uri="{FF2B5EF4-FFF2-40B4-BE49-F238E27FC236}">
-                <a16:creationId xmlns:a16="http://schemas.microsoft.com/office/drawing/2014/main" id="{D9D83BE9-E43B-4792-9994-7B4CE28BFB04}"/>
+                <a16:creationId xmlns:a16="http://schemas.microsoft.com/office/drawing/2014/main" id="{5BFC002F-D4D8-4FCB-AAE2-0819BB3753FD}"/>
               </a:ext>
             </a:extLst>
           </p:cNvPr>
@@ -1867,7 +1796,7 @@
           <p:cNvPr id="5" name="">
             <a:extLst xmlns:a="http://schemas.openxmlformats.org/drawingml/2006/main">
               <a:ext uri="{FF2B5EF4-FFF2-40B4-BE49-F238E27FC236}">
-                <a16:creationId xmlns:a16="http://schemas.microsoft.com/office/drawing/2014/main" id="{C08F80D1-7948-407B-8CDD-603A9F3DB377}"/>
+                <a16:creationId xmlns:a16="http://schemas.microsoft.com/office/drawing/2014/main" id="{B6CC4569-B123-4AF0-8758-D7957C37D8AB}"/>
               </a:ext>
             </a:extLst>
           </p:cNvPr>
@@ -1922,7 +1851,7 @@
     </p:spTree>
     <p:extLst>
       <p:ext uri="{BB962C8B-B14F-4D97-AF65-F5344CB8AC3E}">
-        <p14:creationId xmlns:p14="http://schemas.microsoft.com/office/powerpoint/2010/main" val="1283681059"/>
+        <p14:creationId xmlns:p14="http://schemas.microsoft.com/office/powerpoint/2010/main" val="1974761550"/>
       </p:ext>
     </p:extLst>
   </p:cSld>
@@ -1953,7 +1882,7 @@
           <p:cNvPr id="6" name="">
             <a:extLst xmlns:a="http://schemas.openxmlformats.org/drawingml/2006/main">
               <a:ext uri="{FF2B5EF4-FFF2-40B4-BE49-F238E27FC236}">
-                <a16:creationId xmlns:a16="http://schemas.microsoft.com/office/drawing/2014/main" id="{FD1F36A1-3C46-46ED-9A52-F991C0C14C81}"/>
+                <a16:creationId xmlns:a16="http://schemas.microsoft.com/office/drawing/2014/main" id="{36FA4EC1-DC69-4DFB-BF20-791DCB6B4B0D}"/>
               </a:ext>
             </a:extLst>
           </p:cNvPr>
@@ -2010,7 +1939,7 @@
           <p:cNvPr id="2" name="">
             <a:extLst xmlns:a="http://schemas.openxmlformats.org/drawingml/2006/main">
               <a:ext uri="{FF2B5EF4-FFF2-40B4-BE49-F238E27FC236}">
-                <a16:creationId xmlns:a16="http://schemas.microsoft.com/office/drawing/2014/main" id="{FF729CA9-231E-4ACB-B156-0101846C986C}"/>
+                <a16:creationId xmlns:a16="http://schemas.microsoft.com/office/drawing/2014/main" id="{7589CCB3-2CEA-4808-9245-7C9F1D1391EB}"/>
               </a:ext>
             </a:extLst>
           </p:cNvPr>
@@ -2071,7 +2000,7 @@
           <p:nvPr/>
         </p:nvPicPr>
         <p:blipFill>
-          <a:blip xmlns:r="http://schemas.openxmlformats.org/officeDocument/2006/relationships" xmlns:a="http://schemas.openxmlformats.org/drawingml/2006/main" r:embed="R7f48c729dbda45c6"/>
+          <a:blip xmlns:r="http://schemas.openxmlformats.org/officeDocument/2006/relationships" xmlns:a="http://schemas.openxmlformats.org/drawingml/2006/main" r:embed="Rcbb7ce641c214bbc"/>
           <a:stretch xmlns:a="http://schemas.openxmlformats.org/drawingml/2006/main"/>
         </p:blipFill>
         <p:spPr>
@@ -2089,7 +2018,7 @@
           <p:cNvPr id="4" name="">
             <a:extLst xmlns:a="http://schemas.openxmlformats.org/drawingml/2006/main">
               <a:ext uri="{FF2B5EF4-FFF2-40B4-BE49-F238E27FC236}">
-                <a16:creationId xmlns:a16="http://schemas.microsoft.com/office/drawing/2014/main" id="{0A0807AA-66F6-47FA-A141-1E389019D00E}"/>
+                <a16:creationId xmlns:a16="http://schemas.microsoft.com/office/drawing/2014/main" id="{E5F19502-C608-484E-9FB8-FE152709AEF9}"/>
               </a:ext>
             </a:extLst>
           </p:cNvPr>
@@ -2146,7 +2075,7 @@
           <p:cNvPr id="5" name="">
             <a:extLst xmlns:a="http://schemas.openxmlformats.org/drawingml/2006/main">
               <a:ext uri="{FF2B5EF4-FFF2-40B4-BE49-F238E27FC236}">
-                <a16:creationId xmlns:a16="http://schemas.microsoft.com/office/drawing/2014/main" id="{329719CB-47BB-452C-BC6A-1AE8179C8136}"/>
+                <a16:creationId xmlns:a16="http://schemas.microsoft.com/office/drawing/2014/main" id="{3B21CC45-5BFB-4908-9F67-8F6EFF3A2963}"/>
               </a:ext>
             </a:extLst>
           </p:cNvPr>
@@ -2201,7 +2130,7 @@
     </p:spTree>
     <p:extLst>
       <p:ext uri="{BB962C8B-B14F-4D97-AF65-F5344CB8AC3E}">
-        <p14:creationId xmlns:p14="http://schemas.microsoft.com/office/powerpoint/2010/main" val="1412752540"/>
+        <p14:creationId xmlns:p14="http://schemas.microsoft.com/office/powerpoint/2010/main" val="1589456048"/>
       </p:ext>
     </p:extLst>
   </p:cSld>
@@ -2232,7 +2161,7 @@
           <p:cNvPr id="6" name="">
             <a:extLst xmlns:a="http://schemas.openxmlformats.org/drawingml/2006/main">
               <a:ext uri="{FF2B5EF4-FFF2-40B4-BE49-F238E27FC236}">
-                <a16:creationId xmlns:a16="http://schemas.microsoft.com/office/drawing/2014/main" id="{A38907C2-EABF-496E-862F-EAFE36409F43}"/>
+                <a16:creationId xmlns:a16="http://schemas.microsoft.com/office/drawing/2014/main" id="{1303B957-96EC-48C5-90DA-7D43AB320B89}"/>
               </a:ext>
             </a:extLst>
           </p:cNvPr>
@@ -2289,7 +2218,7 @@
           <p:cNvPr id="2" name="">
             <a:extLst xmlns:a="http://schemas.openxmlformats.org/drawingml/2006/main">
               <a:ext uri="{FF2B5EF4-FFF2-40B4-BE49-F238E27FC236}">
-                <a16:creationId xmlns:a16="http://schemas.microsoft.com/office/drawing/2014/main" id="{80A94FDF-486F-4D18-9ABB-EE1A17153260}"/>
+                <a16:creationId xmlns:a16="http://schemas.microsoft.com/office/drawing/2014/main" id="{B0500F51-436E-4FD9-82F9-4A53DCD2A170}"/>
               </a:ext>
             </a:extLst>
           </p:cNvPr>
@@ -2350,7 +2279,7 @@
           <p:nvPr/>
         </p:nvPicPr>
         <p:blipFill>
-          <a:blip xmlns:r="http://schemas.openxmlformats.org/officeDocument/2006/relationships" xmlns:a="http://schemas.openxmlformats.org/drawingml/2006/main" r:embed="R490e65bfaed446fc"/>
+          <a:blip xmlns:r="http://schemas.openxmlformats.org/officeDocument/2006/relationships" xmlns:a="http://schemas.openxmlformats.org/drawingml/2006/main" r:embed="R43d66e0d88cd488c"/>
           <a:stretch xmlns:a="http://schemas.openxmlformats.org/drawingml/2006/main"/>
         </p:blipFill>
         <p:spPr>
@@ -2368,7 +2297,7 @@
           <p:cNvPr id="4" name="">
             <a:extLst xmlns:a="http://schemas.openxmlformats.org/drawingml/2006/main">
               <a:ext uri="{FF2B5EF4-FFF2-40B4-BE49-F238E27FC236}">
-                <a16:creationId xmlns:a16="http://schemas.microsoft.com/office/drawing/2014/main" id="{B72B94F4-4A4C-4A34-93EC-D10EC16B609F}"/>
+                <a16:creationId xmlns:a16="http://schemas.microsoft.com/office/drawing/2014/main" id="{72A6E95D-AC0C-434C-9077-6A26D8A00703}"/>
               </a:ext>
             </a:extLst>
           </p:cNvPr>
@@ -2425,7 +2354,7 @@
           <p:cNvPr id="5" name="">
             <a:extLst xmlns:a="http://schemas.openxmlformats.org/drawingml/2006/main">
               <a:ext uri="{FF2B5EF4-FFF2-40B4-BE49-F238E27FC236}">
-                <a16:creationId xmlns:a16="http://schemas.microsoft.com/office/drawing/2014/main" id="{3AF5B8B8-E28E-4D02-8908-2F385F19DCAE}"/>
+                <a16:creationId xmlns:a16="http://schemas.microsoft.com/office/drawing/2014/main" id="{F0EA1CD8-8BFF-4C11-96DC-2E80E96D933E}"/>
               </a:ext>
             </a:extLst>
           </p:cNvPr>
@@ -2480,7 +2409,7 @@
     </p:spTree>
     <p:extLst>
       <p:ext uri="{BB962C8B-B14F-4D97-AF65-F5344CB8AC3E}">
-        <p14:creationId xmlns:p14="http://schemas.microsoft.com/office/powerpoint/2010/main" val="2062261699"/>
+        <p14:creationId xmlns:p14="http://schemas.microsoft.com/office/powerpoint/2010/main" val="793452552"/>
       </p:ext>
     </p:extLst>
   </p:cSld>
@@ -2511,7 +2440,7 @@
           <p:cNvPr id="6" name="">
             <a:extLst xmlns:a="http://schemas.openxmlformats.org/drawingml/2006/main">
               <a:ext uri="{FF2B5EF4-FFF2-40B4-BE49-F238E27FC236}">
-                <a16:creationId xmlns:a16="http://schemas.microsoft.com/office/drawing/2014/main" id="{7B3DD3F7-8C76-4426-8D4E-5CE63A6DB063}"/>
+                <a16:creationId xmlns:a16="http://schemas.microsoft.com/office/drawing/2014/main" id="{1E774339-BA3B-49F4-900B-0DF75D3DEE3D}"/>
               </a:ext>
             </a:extLst>
           </p:cNvPr>
@@ -2568,7 +2497,7 @@
           <p:cNvPr id="2" name="">
             <a:extLst xmlns:a="http://schemas.openxmlformats.org/drawingml/2006/main">
               <a:ext uri="{FF2B5EF4-FFF2-40B4-BE49-F238E27FC236}">
-                <a16:creationId xmlns:a16="http://schemas.microsoft.com/office/drawing/2014/main" id="{5E92EBE4-6BEA-4DFC-92C4-55EE38377124}"/>
+                <a16:creationId xmlns:a16="http://schemas.microsoft.com/office/drawing/2014/main" id="{373DCB7A-9B30-4401-8CE0-A140967FBDE1}"/>
               </a:ext>
             </a:extLst>
           </p:cNvPr>
@@ -2629,7 +2558,7 @@
           <p:nvPr/>
         </p:nvPicPr>
         <p:blipFill>
-          <a:blip xmlns:r="http://schemas.openxmlformats.org/officeDocument/2006/relationships" xmlns:a="http://schemas.openxmlformats.org/drawingml/2006/main" r:embed="R0fb3f967aea74107"/>
+          <a:blip xmlns:r="http://schemas.openxmlformats.org/officeDocument/2006/relationships" xmlns:a="http://schemas.openxmlformats.org/drawingml/2006/main" r:embed="Rb3b974904df24d57"/>
           <a:stretch xmlns:a="http://schemas.openxmlformats.org/drawingml/2006/main"/>
         </p:blipFill>
         <p:spPr>
@@ -2647,7 +2576,7 @@
           <p:cNvPr id="4" name="">
             <a:extLst xmlns:a="http://schemas.openxmlformats.org/drawingml/2006/main">
               <a:ext uri="{FF2B5EF4-FFF2-40B4-BE49-F238E27FC236}">
-                <a16:creationId xmlns:a16="http://schemas.microsoft.com/office/drawing/2014/main" id="{AF00F428-5656-446E-89F7-69EE7BE4C171}"/>
+                <a16:creationId xmlns:a16="http://schemas.microsoft.com/office/drawing/2014/main" id="{9FBD5E50-D931-431B-B1A5-62F6366C3432}"/>
               </a:ext>
             </a:extLst>
           </p:cNvPr>
@@ -2727,7 +2656,7 @@
           <p:cNvPr id="5" name="">
             <a:extLst xmlns:a="http://schemas.openxmlformats.org/drawingml/2006/main">
               <a:ext uri="{FF2B5EF4-FFF2-40B4-BE49-F238E27FC236}">
-                <a16:creationId xmlns:a16="http://schemas.microsoft.com/office/drawing/2014/main" id="{4519AFD0-811A-48C9-A68E-02893D6F79B6}"/>
+                <a16:creationId xmlns:a16="http://schemas.microsoft.com/office/drawing/2014/main" id="{9DCD894B-349B-4AAB-BCCB-8968A042BC3C}"/>
               </a:ext>
             </a:extLst>
           </p:cNvPr>
@@ -2782,7 +2711,7 @@
     </p:spTree>
     <p:extLst>
       <p:ext uri="{BB962C8B-B14F-4D97-AF65-F5344CB8AC3E}">
-        <p14:creationId xmlns:p14="http://schemas.microsoft.com/office/powerpoint/2010/main" val="792599811"/>
+        <p14:creationId xmlns:p14="http://schemas.microsoft.com/office/powerpoint/2010/main" val="165988336"/>
       </p:ext>
     </p:extLst>
   </p:cSld>
@@ -2813,7 +2742,7 @@
           <p:cNvPr id="6" name="">
             <a:extLst xmlns:a="http://schemas.openxmlformats.org/drawingml/2006/main">
               <a:ext uri="{FF2B5EF4-FFF2-40B4-BE49-F238E27FC236}">
-                <a16:creationId xmlns:a16="http://schemas.microsoft.com/office/drawing/2014/main" id="{FF4407A8-1D71-4B1B-997F-7AF4B9C61D49}"/>
+                <a16:creationId xmlns:a16="http://schemas.microsoft.com/office/drawing/2014/main" id="{F9909D66-0576-4497-B1D7-59D765A6408A}"/>
               </a:ext>
             </a:extLst>
           </p:cNvPr>
@@ -2870,7 +2799,7 @@
           <p:cNvPr id="2" name="">
             <a:extLst xmlns:a="http://schemas.openxmlformats.org/drawingml/2006/main">
               <a:ext uri="{FF2B5EF4-FFF2-40B4-BE49-F238E27FC236}">
-                <a16:creationId xmlns:a16="http://schemas.microsoft.com/office/drawing/2014/main" id="{52A19903-F664-422C-B4F6-FF32B7FE330B}"/>
+                <a16:creationId xmlns:a16="http://schemas.microsoft.com/office/drawing/2014/main" id="{4A8C47CB-1DF3-47CA-8353-43A5FF55D6EF}"/>
               </a:ext>
             </a:extLst>
           </p:cNvPr>
@@ -3320,7 +3249,7 @@
           <p:cNvPr id="4" name="">
             <a:extLst xmlns:a="http://schemas.openxmlformats.org/drawingml/2006/main">
               <a:ext uri="{FF2B5EF4-FFF2-40B4-BE49-F238E27FC236}">
-                <a16:creationId xmlns:a16="http://schemas.microsoft.com/office/drawing/2014/main" id="{25904368-353D-4440-9CC6-A38842B1F2B4}"/>
+                <a16:creationId xmlns:a16="http://schemas.microsoft.com/office/drawing/2014/main" id="{0B8B1444-FFC0-4BBE-A1A8-3EE0B00CB066}"/>
               </a:ext>
             </a:extLst>
           </p:cNvPr>
@@ -3377,7 +3306,7 @@
           <p:cNvPr id="5" name="">
             <a:extLst xmlns:a="http://schemas.openxmlformats.org/drawingml/2006/main">
               <a:ext uri="{FF2B5EF4-FFF2-40B4-BE49-F238E27FC236}">
-                <a16:creationId xmlns:a16="http://schemas.microsoft.com/office/drawing/2014/main" id="{9166ED27-3CE1-4A5F-A07A-154E17D8EEEE}"/>
+                <a16:creationId xmlns:a16="http://schemas.microsoft.com/office/drawing/2014/main" id="{B5B9D283-B97D-479A-9EE7-9E5D7B6868E1}"/>
               </a:ext>
             </a:extLst>
           </p:cNvPr>
@@ -3432,7 +3361,7 @@
     </p:spTree>
     <p:extLst>
       <p:ext uri="{BB962C8B-B14F-4D97-AF65-F5344CB8AC3E}">
-        <p14:creationId xmlns:p14="http://schemas.microsoft.com/office/powerpoint/2010/main" val="1458220293"/>
+        <p14:creationId xmlns:p14="http://schemas.microsoft.com/office/powerpoint/2010/main" val="1159001542"/>
       </p:ext>
     </p:extLst>
   </p:cSld>
@@ -3463,7 +3392,7 @@
           <p:cNvPr id="5" name="">
             <a:extLst xmlns:a="http://schemas.openxmlformats.org/drawingml/2006/main">
               <a:ext uri="{FF2B5EF4-FFF2-40B4-BE49-F238E27FC236}">
-                <a16:creationId xmlns:a16="http://schemas.microsoft.com/office/drawing/2014/main" id="{B7389CD8-B233-4064-9FF0-32BBAB4E03CE}"/>
+                <a16:creationId xmlns:a16="http://schemas.microsoft.com/office/drawing/2014/main" id="{2694B76E-E45C-401C-BD79-3EF5C7A48C89}"/>
               </a:ext>
             </a:extLst>
           </p:cNvPr>
@@ -3520,7 +3449,7 @@
           <p:cNvPr id="2" name="">
             <a:extLst xmlns:a="http://schemas.openxmlformats.org/drawingml/2006/main">
               <a:ext uri="{FF2B5EF4-FFF2-40B4-BE49-F238E27FC236}">
-                <a16:creationId xmlns:a16="http://schemas.microsoft.com/office/drawing/2014/main" id="{58CC21DE-6B47-4D51-A1C6-65A1ECE12D02}"/>
+                <a16:creationId xmlns:a16="http://schemas.microsoft.com/office/drawing/2014/main" id="{61AA27B7-5B98-40EA-834D-6D4B972173C5}"/>
               </a:ext>
             </a:extLst>
           </p:cNvPr>
@@ -3577,7 +3506,7 @@
           <p:cNvPr id="3" name="">
             <a:extLst xmlns:a="http://schemas.openxmlformats.org/drawingml/2006/main">
               <a:ext uri="{FF2B5EF4-FFF2-40B4-BE49-F238E27FC236}">
-                <a16:creationId xmlns:a16="http://schemas.microsoft.com/office/drawing/2014/main" id="{7FE59135-FBC0-49E7-877E-7B77A9BCBF52}"/>
+                <a16:creationId xmlns:a16="http://schemas.microsoft.com/office/drawing/2014/main" id="{A97043D6-6E49-46F0-B82C-6C139F41808A}"/>
               </a:ext>
             </a:extLst>
           </p:cNvPr>
@@ -3718,7 +3647,7 @@
           <p:cNvPr id="4" name="">
             <a:extLst xmlns:a="http://schemas.openxmlformats.org/drawingml/2006/main">
               <a:ext uri="{FF2B5EF4-FFF2-40B4-BE49-F238E27FC236}">
-                <a16:creationId xmlns:a16="http://schemas.microsoft.com/office/drawing/2014/main" id="{10712E07-1969-4498-BC4C-7A3F42F9FFF0}"/>
+                <a16:creationId xmlns:a16="http://schemas.microsoft.com/office/drawing/2014/main" id="{D7A922BA-30AD-4DE0-8FE0-C2FB6ECABF6F}"/>
               </a:ext>
             </a:extLst>
           </p:cNvPr>
@@ -3773,7 +3702,7 @@
     </p:spTree>
     <p:extLst>
       <p:ext uri="{BB962C8B-B14F-4D97-AF65-F5344CB8AC3E}">
-        <p14:creationId xmlns:p14="http://schemas.microsoft.com/office/powerpoint/2010/main" val="421024705"/>
+        <p14:creationId xmlns:p14="http://schemas.microsoft.com/office/powerpoint/2010/main" val="364023730"/>
       </p:ext>
     </p:extLst>
   </p:cSld>
@@ -3804,7 +3733,7 @@
           <p:cNvPr id="6" name="">
             <a:extLst xmlns:a="http://schemas.openxmlformats.org/drawingml/2006/main">
               <a:ext uri="{FF2B5EF4-FFF2-40B4-BE49-F238E27FC236}">
-                <a16:creationId xmlns:a16="http://schemas.microsoft.com/office/drawing/2014/main" id="{9DB4F53B-EB67-418F-8975-2A045EAB990D}"/>
+                <a16:creationId xmlns:a16="http://schemas.microsoft.com/office/drawing/2014/main" id="{181A92DC-BC9B-4288-8E3C-38BC2D93D4F6}"/>
               </a:ext>
             </a:extLst>
           </p:cNvPr>
@@ -3861,7 +3790,7 @@
           <p:cNvPr id="2" name="">
             <a:extLst xmlns:a="http://schemas.openxmlformats.org/drawingml/2006/main">
               <a:ext uri="{FF2B5EF4-FFF2-40B4-BE49-F238E27FC236}">
-                <a16:creationId xmlns:a16="http://schemas.microsoft.com/office/drawing/2014/main" id="{963D3A20-F3F0-41E3-B494-BE9DF7D3B7C8}"/>
+                <a16:creationId xmlns:a16="http://schemas.microsoft.com/office/drawing/2014/main" id="{D96DB610-09B3-47E4-A0DF-A2A5D93BFE3A}"/>
               </a:ext>
             </a:extLst>
           </p:cNvPr>
@@ -4334,7 +4263,7 @@
           <p:cNvPr id="4" name="">
             <a:extLst xmlns:a="http://schemas.openxmlformats.org/drawingml/2006/main">
               <a:ext uri="{FF2B5EF4-FFF2-40B4-BE49-F238E27FC236}">
-                <a16:creationId xmlns:a16="http://schemas.microsoft.com/office/drawing/2014/main" id="{C47BC983-BBE4-42C0-81FD-05D271043958}"/>
+                <a16:creationId xmlns:a16="http://schemas.microsoft.com/office/drawing/2014/main" id="{794C6063-7DCE-449F-BD2C-4C08C7706972}"/>
               </a:ext>
             </a:extLst>
           </p:cNvPr>
@@ -4414,7 +4343,7 @@
           <p:cNvPr id="5" name="">
             <a:extLst xmlns:a="http://schemas.openxmlformats.org/drawingml/2006/main">
               <a:ext uri="{FF2B5EF4-FFF2-40B4-BE49-F238E27FC236}">
-                <a16:creationId xmlns:a16="http://schemas.microsoft.com/office/drawing/2014/main" id="{6B31DFED-B873-4A95-8F51-40FDFCD81C85}"/>
+                <a16:creationId xmlns:a16="http://schemas.microsoft.com/office/drawing/2014/main" id="{E19729E4-F8AB-46AA-BECB-D5D831D9E807}"/>
               </a:ext>
             </a:extLst>
           </p:cNvPr>
@@ -4469,366 +4398,7 @@
     </p:spTree>
     <p:extLst>
       <p:ext uri="{BB962C8B-B14F-4D97-AF65-F5344CB8AC3E}">
-        <p14:creationId xmlns:p14="http://schemas.microsoft.com/office/powerpoint/2010/main" val="2076779879"/>
-      </p:ext>
-    </p:extLst>
-  </p:cSld>
-</p:sld>
-</file>
-
-<file path=ppt/slides/slide8.xml><?xml version="1.0" encoding="utf-8"?>
-<p:sld xmlns:p="http://schemas.openxmlformats.org/presentationml/2006/main">
-  <p:cSld>
-    <p:bg>
-      <p:bgPr>
-        <a:solidFill xmlns:a="http://schemas.openxmlformats.org/drawingml/2006/main">
-          <a:srgbClr val="FFFFFF"/>
-        </a:solidFill>
-      </p:bgPr>
-    </p:bg>
-    <p:spTree>
-      <p:nvGrpSpPr>
-        <p:cNvPr id="1" name=""/>
-        <p:cNvGrpSpPr/>
-        <p:nvPr/>
-      </p:nvGrpSpPr>
-      <p:grpSpPr>
-        <a:xfrm xmlns:a="http://schemas.openxmlformats.org/drawingml/2006/main"/>
-      </p:grpSpPr>
-      <p:sp>
-        <p:nvSpPr>
-          <p:cNvPr id="5" name="">
-            <a:extLst xmlns:a="http://schemas.openxmlformats.org/drawingml/2006/main">
-              <a:ext uri="{FF2B5EF4-FFF2-40B4-BE49-F238E27FC236}">
-                <a16:creationId xmlns:a16="http://schemas.microsoft.com/office/drawing/2014/main" id="{23AEE0BC-01D7-484C-A796-1524BC3BF792}"/>
-              </a:ext>
-            </a:extLst>
-          </p:cNvPr>
-          <p:cNvSpPr>
-            <a:spLocks xmlns:a="http://schemas.openxmlformats.org/drawingml/2006/main" noGrp="1"/>
-          </p:cNvSpPr>
-          <p:nvPr/>
-        </p:nvSpPr>
-        <p:spPr>
-          <a:xfrm xmlns:a="http://schemas.openxmlformats.org/drawingml/2006/main">
-            <a:off x="685800" y="457200"/>
-            <a:ext cx="10820400" cy="952500"/>
-          </a:xfrm>
-          <a:prstGeom xmlns:a="http://schemas.openxmlformats.org/drawingml/2006/main" prst="rect">
-            <a:avLst/>
-          </a:prstGeom>
-          <a:noFill xmlns:a="http://schemas.openxmlformats.org/drawingml/2006/main"/>
-          <a:ln xmlns:a="http://schemas.openxmlformats.org/drawingml/2006/main" w="0">
-            <a:noFill/>
-          </a:ln>
-        </p:spPr>
-        <p:txBody>
-          <a:bodyPr xmlns:a="http://schemas.openxmlformats.org/drawingml/2006/main">
-            <a:noAutofit/>
-          </a:bodyPr>
-          <a:lstStyle xmlns:a="http://schemas.openxmlformats.org/drawingml/2006/main"/>
-          <a:p xmlns:a="http://schemas.openxmlformats.org/drawingml/2006/main">
-            <a:pPr>
-              <a:defRPr sz="3300" b="1">
-                <a:solidFill>
-                  <a:srgbClr val="173544"/>
-                </a:solidFill>
-                <a:latin typeface="Arial"/>
-                <a:ea typeface="Arial"/>
-                <a:cs typeface="Arial"/>
-              </a:defRPr>
-            </a:pPr>
-            <a:r>
-              <a:rPr sz="3300" b="1">
-                <a:solidFill>
-                  <a:srgbClr val="173544"/>
-                </a:solidFill>
-                <a:latin typeface="Arial"/>
-                <a:ea typeface="Arial"/>
-                <a:cs typeface="Arial"/>
-              </a:rPr>
-              <a:t>Что удалось воспроизвести</a:t>
-            </a:r>
-          </a:p>
-        </p:txBody>
-      </p:sp>
-      <p:sp>
-        <p:nvSpPr>
-          <p:cNvPr id="2" name="">
-            <a:extLst xmlns:a="http://schemas.openxmlformats.org/drawingml/2006/main">
-              <a:ext uri="{FF2B5EF4-FFF2-40B4-BE49-F238E27FC236}">
-                <a16:creationId xmlns:a16="http://schemas.microsoft.com/office/drawing/2014/main" id="{FFEB626F-88A5-45B2-8A07-83A615C654EB}"/>
-              </a:ext>
-            </a:extLst>
-          </p:cNvPr>
-          <p:cNvSpPr>
-            <a:spLocks xmlns:a="http://schemas.openxmlformats.org/drawingml/2006/main" noGrp="1"/>
-          </p:cNvSpPr>
-          <p:nvPr/>
-        </p:nvSpPr>
-        <p:spPr>
-          <a:xfrm xmlns:a="http://schemas.openxmlformats.org/drawingml/2006/main">
-            <a:off x="685800" y="1571625"/>
-            <a:ext cx="10820400" cy="1190625"/>
-          </a:xfrm>
-          <a:prstGeom xmlns:a="http://schemas.openxmlformats.org/drawingml/2006/main" prst="rect">
-            <a:avLst/>
-          </a:prstGeom>
-          <a:noFill xmlns:a="http://schemas.openxmlformats.org/drawingml/2006/main"/>
-          <a:ln xmlns:a="http://schemas.openxmlformats.org/drawingml/2006/main" w="0">
-            <a:noFill/>
-          </a:ln>
-        </p:spPr>
-        <p:txBody>
-          <a:bodyPr xmlns:a="http://schemas.openxmlformats.org/drawingml/2006/main">
-            <a:noAutofit/>
-          </a:bodyPr>
-          <a:lstStyle xmlns:a="http://schemas.openxmlformats.org/drawingml/2006/main"/>
-          <a:p xmlns:a="http://schemas.openxmlformats.org/drawingml/2006/main">
-            <a:pPr>
-              <a:defRPr sz="2850" b="1">
-                <a:solidFill>
-                  <a:srgbClr val="087E8B"/>
-                </a:solidFill>
-                <a:latin typeface="Arial"/>
-                <a:ea typeface="Arial"/>
-                <a:cs typeface="Arial"/>
-              </a:defRPr>
-            </a:pPr>
-            <a:r>
-              <a:rPr sz="2850" b="1">
-                <a:solidFill>
-                  <a:srgbClr val="087E8B"/>
-                </a:solidFill>
-                <a:latin typeface="Arial"/>
-                <a:ea typeface="Arial"/>
-                <a:cs typeface="Arial"/>
-              </a:rPr>
-              <a:t>Запущены код авторов, структурные проверки</a:t>
-            </a:r>
-          </a:p>
-          <a:p xmlns:a="http://schemas.openxmlformats.org/drawingml/2006/main">
-            <a:pPr>
-              <a:defRPr sz="2850" b="1">
-                <a:solidFill>
-                  <a:srgbClr val="087E8B"/>
-                </a:solidFill>
-                <a:latin typeface="Arial"/>
-                <a:ea typeface="Arial"/>
-                <a:cs typeface="Arial"/>
-              </a:defRPr>
-            </a:pPr>
-            <a:r>
-              <a:rPr sz="2850" b="1">
-                <a:solidFill>
-                  <a:srgbClr val="087E8B"/>
-                </a:solidFill>
-                <a:latin typeface="Arial"/>
-                <a:ea typeface="Arial"/>
-                <a:cs typeface="Arial"/>
-              </a:rPr>
-              <a:t>и сокращенная абляция на pretrained SmolLM.</a:t>
-            </a:r>
-          </a:p>
-        </p:txBody>
-      </p:sp>
-      <p:sp>
-        <p:nvSpPr>
-          <p:cNvPr id="3" name="">
-            <a:extLst xmlns:a="http://schemas.openxmlformats.org/drawingml/2006/main">
-              <a:ext uri="{FF2B5EF4-FFF2-40B4-BE49-F238E27FC236}">
-                <a16:creationId xmlns:a16="http://schemas.microsoft.com/office/drawing/2014/main" id="{7F8B5AE1-9486-4F2A-BF68-4422A07FCDF8}"/>
-              </a:ext>
-            </a:extLst>
-          </p:cNvPr>
-          <p:cNvSpPr>
-            <a:spLocks xmlns:a="http://schemas.openxmlformats.org/drawingml/2006/main" noGrp="1"/>
-          </p:cNvSpPr>
-          <p:nvPr/>
-        </p:nvSpPr>
-        <p:spPr>
-          <a:xfrm xmlns:a="http://schemas.openxmlformats.org/drawingml/2006/main">
-            <a:off x="685800" y="3286125"/>
-            <a:ext cx="10820400" cy="2762250"/>
-          </a:xfrm>
-          <a:prstGeom xmlns:a="http://schemas.openxmlformats.org/drawingml/2006/main" prst="rect">
-            <a:avLst/>
-          </a:prstGeom>
-          <a:noFill xmlns:a="http://schemas.openxmlformats.org/drawingml/2006/main"/>
-          <a:ln xmlns:a="http://schemas.openxmlformats.org/drawingml/2006/main" w="0">
-            <a:noFill/>
-          </a:ln>
-        </p:spPr>
-        <p:txBody>
-          <a:bodyPr xmlns:a="http://schemas.openxmlformats.org/drawingml/2006/main">
-            <a:noAutofit/>
-          </a:bodyPr>
-          <a:lstStyle xmlns:a="http://schemas.openxmlformats.org/drawingml/2006/main"/>
-          <a:p xmlns:a="http://schemas.openxmlformats.org/drawingml/2006/main">
-            <a:pPr>
-              <a:defRPr sz="2175" b="0">
-                <a:solidFill>
-                  <a:srgbClr val="173544"/>
-                </a:solidFill>
-                <a:latin typeface="Arial"/>
-                <a:ea typeface="Arial"/>
-                <a:cs typeface="Arial"/>
-              </a:defRPr>
-            </a:pPr>
-            <a:r>
-              <a:rPr sz="2175" b="0">
-                <a:solidFill>
-                  <a:srgbClr val="173544"/>
-                </a:solidFill>
-                <a:latin typeface="Arial"/>
-                <a:ea typeface="Arial"/>
-                <a:cs typeface="Arial"/>
-              </a:rPr>
-              <a:t>Проверен доступ к готовому checkpoint Llama-2-7B-DroPE.</a:t>
-            </a:r>
-          </a:p>
-          <a:p xmlns:a="http://schemas.openxmlformats.org/drawingml/2006/main">
-            <a:pPr>
-              <a:defRPr sz="2175" b="0">
-                <a:solidFill>
-                  <a:srgbClr val="173544"/>
-                </a:solidFill>
-                <a:latin typeface="Arial"/>
-                <a:ea typeface="Arial"/>
-                <a:cs typeface="Arial"/>
-              </a:defRPr>
-            </a:pPr>
-            <a:r>
-              <a:rPr sz="2175" b="0">
-                <a:solidFill>
-                  <a:srgbClr val="173544"/>
-                </a:solidFill>
-                <a:latin typeface="Arial"/>
-                <a:ea typeface="Arial"/>
-                <a:cs typeface="Arial"/>
-              </a:rPr>
-              <a:t>Полный инференс 7B и LongBench остаются за рамками запуска.</a:t>
-            </a:r>
-          </a:p>
-          <a:p xmlns:a="http://schemas.openxmlformats.org/drawingml/2006/main">
-            <a:r>
-              <a:t/>
-            </a:r>
-          </a:p>
-          <a:p xmlns:a="http://schemas.openxmlformats.org/drawingml/2006/main">
-            <a:pPr>
-              <a:defRPr sz="2175" b="0">
-                <a:solidFill>
-                  <a:srgbClr val="173544"/>
-                </a:solidFill>
-                <a:latin typeface="Arial"/>
-                <a:ea typeface="Arial"/>
-                <a:cs typeface="Arial"/>
-              </a:defRPr>
-            </a:pPr>
-            <a:r>
-              <a:rPr sz="2175" b="0">
-                <a:solidFill>
-                  <a:srgbClr val="173544"/>
-                </a:solidFill>
-                <a:latin typeface="Arial"/>
-                <a:ea typeface="Arial"/>
-                <a:cs typeface="Arial"/>
-              </a:rPr>
-              <a:t>DroPE требует рекалибровки. Размер ее бюджета влияет на результат.</a:t>
-            </a:r>
-          </a:p>
-          <a:p xmlns:a="http://schemas.openxmlformats.org/drawingml/2006/main">
-            <a:r>
-              <a:t/>
-            </a:r>
-          </a:p>
-          <a:p xmlns:a="http://schemas.openxmlformats.org/drawingml/2006/main">
-            <a:pPr>
-              <a:defRPr sz="2175" b="0">
-                <a:solidFill>
-                  <a:srgbClr val="173544"/>
-                </a:solidFill>
-                <a:latin typeface="Arial"/>
-                <a:ea typeface="Arial"/>
-                <a:cs typeface="Arial"/>
-              </a:defRPr>
-            </a:pPr>
-            <a:r>
-              <a:rPr sz="2175" b="0">
-                <a:solidFill>
-                  <a:srgbClr val="173544"/>
-                </a:solidFill>
-                <a:latin typeface="Arial"/>
-                <a:ea typeface="Arial"/>
-                <a:cs typeface="Arial"/>
-              </a:rPr>
-              <a:t>Для сдачи: презентация, отчет, код и фактические логи.</a:t>
-            </a:r>
-          </a:p>
-        </p:txBody>
-      </p:sp>
-      <p:sp>
-        <p:nvSpPr>
-          <p:cNvPr id="4" name="">
-            <a:extLst xmlns:a="http://schemas.openxmlformats.org/drawingml/2006/main">
-              <a:ext uri="{FF2B5EF4-FFF2-40B4-BE49-F238E27FC236}">
-                <a16:creationId xmlns:a16="http://schemas.microsoft.com/office/drawing/2014/main" id="{7A33F4CF-ABCE-4015-B074-3FB086D87272}"/>
-              </a:ext>
-            </a:extLst>
-          </p:cNvPr>
-          <p:cNvSpPr>
-            <a:spLocks xmlns:a="http://schemas.openxmlformats.org/drawingml/2006/main" noGrp="1"/>
-          </p:cNvSpPr>
-          <p:nvPr/>
-        </p:nvSpPr>
-        <p:spPr>
-          <a:xfrm xmlns:a="http://schemas.openxmlformats.org/drawingml/2006/main">
-            <a:off x="11144250" y="6448425"/>
-            <a:ext cx="333375" cy="266700"/>
-          </a:xfrm>
-          <a:prstGeom xmlns:a="http://schemas.openxmlformats.org/drawingml/2006/main" prst="rect">
-            <a:avLst/>
-          </a:prstGeom>
-          <a:noFill xmlns:a="http://schemas.openxmlformats.org/drawingml/2006/main"/>
-          <a:ln xmlns:a="http://schemas.openxmlformats.org/drawingml/2006/main" w="0">
-            <a:noFill/>
-          </a:ln>
-        </p:spPr>
-        <p:txBody>
-          <a:bodyPr xmlns:a="http://schemas.openxmlformats.org/drawingml/2006/main">
-            <a:noAutofit/>
-          </a:bodyPr>
-          <a:lstStyle xmlns:a="http://schemas.openxmlformats.org/drawingml/2006/main"/>
-          <a:p xmlns:a="http://schemas.openxmlformats.org/drawingml/2006/main">
-            <a:pPr>
-              <a:defRPr sz="1350" b="0">
-                <a:solidFill>
-                  <a:srgbClr val="48606B"/>
-                </a:solidFill>
-                <a:latin typeface="Arial"/>
-                <a:ea typeface="Arial"/>
-                <a:cs typeface="Arial"/>
-              </a:defRPr>
-            </a:pPr>
-            <a:r>
-              <a:rPr sz="1350" b="0">
-                <a:solidFill>
-                  <a:srgbClr val="48606B"/>
-                </a:solidFill>
-                <a:latin typeface="Arial"/>
-                <a:ea typeface="Arial"/>
-                <a:cs typeface="Arial"/>
-              </a:rPr>
-              <a:t>8</a:t>
-            </a:r>
-          </a:p>
-        </p:txBody>
-      </p:sp>
-    </p:spTree>
-    <p:extLst>
-      <p:ext uri="{BB962C8B-B14F-4D97-AF65-F5344CB8AC3E}">
-        <p14:creationId xmlns:p14="http://schemas.microsoft.com/office/powerpoint/2010/main" val="432306165"/>
+        <p14:creationId xmlns:p14="http://schemas.microsoft.com/office/powerpoint/2010/main" val="266564030"/>
       </p:ext>
     </p:extLst>
   </p:cSld>

</xml_diff>